<commit_message>
Add Window and TextButton types
Signed-off-by: Andreas Bank <andreas.bank@n3rd.se>
</commit_message>
<xml_diff>
--- a/map_ generation.pptx
+++ b/map_ generation.pptx
@@ -4931,7 +4931,7 @@
         <p:spPr>
           <a:xfrm>
             <a:off x="228600" y="914400"/>
-            <a:ext cx="2743200" cy="3291840"/>
+            <a:ext cx="2743200" cy="2483893"/>
           </a:xfrm>
           <a:prstGeom prst="rect">
             <a:avLst/>
@@ -5102,7 +5102,7 @@
         <p:spPr>
           <a:xfrm>
             <a:off x="3200400" y="914400"/>
-            <a:ext cx="2743200" cy="3291840"/>
+            <a:ext cx="2743200" cy="2483893"/>
           </a:xfrm>
           <a:prstGeom prst="rect">
             <a:avLst/>
@@ -5273,7 +5273,7 @@
         <p:spPr>
           <a:xfrm>
             <a:off x="6172200" y="914400"/>
-            <a:ext cx="2743200" cy="3291840"/>
+            <a:ext cx="2743200" cy="2483893"/>
           </a:xfrm>
           <a:prstGeom prst="rect">
             <a:avLst/>
@@ -5443,8 +5443,8 @@
         </p:nvSpPr>
         <p:spPr>
           <a:xfrm>
-            <a:off x="228600" y="4251960"/>
-            <a:ext cx="8686800" cy="749808"/>
+            <a:off x="228600" y="3489733"/>
+            <a:ext cx="8686800" cy="1512035"/>
           </a:xfrm>
           <a:prstGeom prst="rect">
             <a:avLst/>
@@ -5475,7 +5475,7 @@
         </p:nvSpPr>
         <p:spPr>
           <a:xfrm>
-            <a:off x="228600" y="4251960"/>
+            <a:off x="324134" y="3478929"/>
             <a:ext cx="8686800" cy="256032"/>
           </a:xfrm>
           <a:prstGeom prst="rect">
@@ -5514,7 +5514,7 @@
         </p:nvSpPr>
         <p:spPr>
           <a:xfrm>
-            <a:off x="228600" y="4507992"/>
+            <a:off x="324134" y="3684623"/>
             <a:ext cx="8686800" cy="493776"/>
           </a:xfrm>
           <a:prstGeom prst="rect">
@@ -9188,7 +9188,7 @@
         </p:nvSpPr>
         <p:spPr>
           <a:xfrm>
-            <a:off x="137160" y="1493293"/>
+            <a:off x="210312" y="1543744"/>
             <a:ext cx="8759952" cy="256032"/>
           </a:xfrm>
           <a:prstGeom prst="rect">
@@ -9227,7 +9227,7 @@
         </p:nvSpPr>
         <p:spPr>
           <a:xfrm>
-            <a:off x="137160" y="1749325"/>
+            <a:off x="210312" y="1755376"/>
             <a:ext cx="8759952" cy="3277600"/>
           </a:xfrm>
           <a:prstGeom prst="rect">

</xml_diff>